<commit_message>
Re #50 minor changes and improvements to the picture
</commit_message>
<xml_diff>
--- a/source/images/tutorial/LipidMonolayerAndProperties.pptx
+++ b/source/images/tutorial/LipidMonolayerAndProperties.pptx
@@ -104,6 +104,11 @@
       </a:defRPr>
     </a:lvl9pPr>
   </p:defaultTextStyle>
+  <p:extLst>
+    <p:ext uri="{EFAFB233-063F-42B5-8137-9DF3F51BA10A}">
+      <p15:sldGuideLst xmlns:p15="http://schemas.microsoft.com/office/powerpoint/2012/main"/>
+    </p:ext>
+  </p:extLst>
 </p:presentation>
 </file>
 
@@ -3674,7 +3679,7 @@
               <a:p>
                 <a:r>
                   <a:rPr lang="en-GB" dirty="0"/>
-                  <a:t>Prop: Thickness:2</a:t>
+                  <a:t>Thickness:2</a:t>
                 </a:r>
               </a:p>
             </p:txBody>
@@ -3722,7 +3727,7 @@
               <a:p>
                 <a:r>
                   <a:rPr lang="en-GB" dirty="0"/>
-                  <a:t>Prop: SLD:2</a:t>
+                  <a:t>SLD:2</a:t>
                 </a:r>
               </a:p>
             </p:txBody>
@@ -3770,7 +3775,7 @@
               <a:p>
                 <a:r>
                   <a:rPr lang="en-GB" dirty="0"/>
-                  <a:t>Prop: Roughness:</a:t>
+                  <a:t>Roughness:</a:t>
                 </a:r>
                 <a:r>
                   <a:rPr lang="en-GB" sz="1600" dirty="0"/>
@@ -3795,10 +3800,10 @@
           </p:nvGrpSpPr>
           <p:grpSpPr>
             <a:xfrm>
-              <a:off x="4621892" y="4458312"/>
-              <a:ext cx="2218924" cy="1037838"/>
-              <a:chOff x="4621892" y="4458312"/>
-              <a:chExt cx="2218924" cy="1037838"/>
+              <a:off x="4631428" y="4401751"/>
+              <a:ext cx="2218924" cy="1142531"/>
+              <a:chOff x="4631428" y="4401751"/>
+              <a:chExt cx="2218924" cy="1142531"/>
             </a:xfrm>
           </p:grpSpPr>
           <p:sp>
@@ -3815,7 +3820,7 @@
             </p:nvSpPr>
             <p:spPr>
               <a:xfrm>
-                <a:off x="4621892" y="5195643"/>
+                <a:off x="4631428" y="5243775"/>
                 <a:ext cx="2218923" cy="300507"/>
               </a:xfrm>
               <a:prstGeom prst="rect">
@@ -3876,7 +3881,7 @@
             </p:nvSpPr>
             <p:spPr>
               <a:xfrm>
-                <a:off x="4621892" y="4825867"/>
+                <a:off x="4631428" y="4871941"/>
                 <a:ext cx="2218923" cy="300507"/>
               </a:xfrm>
               <a:prstGeom prst="rect">
@@ -3905,7 +3910,7 @@
               <a:p>
                 <a:r>
                   <a:rPr lang="en-GB" dirty="0"/>
-                  <a:t>Prop: SLD-Out</a:t>
+                  <a:t>SLD-Out</a:t>
                 </a:r>
               </a:p>
             </p:txBody>
@@ -3924,8 +3929,8 @@
             </p:nvSpPr>
             <p:spPr>
               <a:xfrm>
-                <a:off x="4621893" y="4458312"/>
-                <a:ext cx="2218923" cy="300507"/>
+                <a:off x="4631429" y="4401751"/>
+                <a:ext cx="2218923" cy="413629"/>
               </a:xfrm>
               <a:prstGeom prst="rect">
                 <a:avLst/>
@@ -3953,11 +3958,17 @@
               <a:p>
                 <a:r>
                   <a:rPr lang="en-GB" dirty="0"/>
-                  <a:t>Prop: Roughness:</a:t>
+                  <a:t>Roughness:</a:t>
                 </a:r>
                 <a:r>
                   <a:rPr lang="en-GB" sz="1600" dirty="0"/>
-                  <a:t>2-3</a:t>
+                  <a:t>2-3 </a:t>
+                </a:r>
+              </a:p>
+              <a:p>
+                <a:r>
+                  <a:rPr lang="en-GB" sz="1600" dirty="0"/>
+                  <a:t>(Substrate roughness)</a:t>
                 </a:r>
                 <a:endParaRPr lang="en-GB" dirty="0"/>
               </a:p>

</xml_diff>

<commit_message>
Re #50 better picture definition and couple of references to it
</commit_message>
<xml_diff>
--- a/source/images/tutorial/LipidMonolayerAndProperties.pptx
+++ b/source/images/tutorial/LipidMonolayerAndProperties.pptx
@@ -261,7 +261,7 @@
           <a:p>
             <a:fld id="{4E93A57C-03BA-4B61-AE4A-2D7B848FC893}" type="datetimeFigureOut">
               <a:rPr lang="en-GB" smtClean="0"/>
-              <a:t>22/08/2025</a:t>
+              <a:t>27/08/2025</a:t>
             </a:fld>
             <a:endParaRPr lang="en-GB"/>
           </a:p>
@@ -461,7 +461,7 @@
           <a:p>
             <a:fld id="{4E93A57C-03BA-4B61-AE4A-2D7B848FC893}" type="datetimeFigureOut">
               <a:rPr lang="en-GB" smtClean="0"/>
-              <a:t>22/08/2025</a:t>
+              <a:t>27/08/2025</a:t>
             </a:fld>
             <a:endParaRPr lang="en-GB"/>
           </a:p>
@@ -671,7 +671,7 @@
           <a:p>
             <a:fld id="{4E93A57C-03BA-4B61-AE4A-2D7B848FC893}" type="datetimeFigureOut">
               <a:rPr lang="en-GB" smtClean="0"/>
-              <a:t>22/08/2025</a:t>
+              <a:t>27/08/2025</a:t>
             </a:fld>
             <a:endParaRPr lang="en-GB"/>
           </a:p>
@@ -871,7 +871,7 @@
           <a:p>
             <a:fld id="{4E93A57C-03BA-4B61-AE4A-2D7B848FC893}" type="datetimeFigureOut">
               <a:rPr lang="en-GB" smtClean="0"/>
-              <a:t>22/08/2025</a:t>
+              <a:t>27/08/2025</a:t>
             </a:fld>
             <a:endParaRPr lang="en-GB"/>
           </a:p>
@@ -1147,7 +1147,7 @@
           <a:p>
             <a:fld id="{4E93A57C-03BA-4B61-AE4A-2D7B848FC893}" type="datetimeFigureOut">
               <a:rPr lang="en-GB" smtClean="0"/>
-              <a:t>22/08/2025</a:t>
+              <a:t>27/08/2025</a:t>
             </a:fld>
             <a:endParaRPr lang="en-GB"/>
           </a:p>
@@ -1415,7 +1415,7 @@
           <a:p>
             <a:fld id="{4E93A57C-03BA-4B61-AE4A-2D7B848FC893}" type="datetimeFigureOut">
               <a:rPr lang="en-GB" smtClean="0"/>
-              <a:t>22/08/2025</a:t>
+              <a:t>27/08/2025</a:t>
             </a:fld>
             <a:endParaRPr lang="en-GB"/>
           </a:p>
@@ -1830,7 +1830,7 @@
           <a:p>
             <a:fld id="{4E93A57C-03BA-4B61-AE4A-2D7B848FC893}" type="datetimeFigureOut">
               <a:rPr lang="en-GB" smtClean="0"/>
-              <a:t>22/08/2025</a:t>
+              <a:t>27/08/2025</a:t>
             </a:fld>
             <a:endParaRPr lang="en-GB"/>
           </a:p>
@@ -1972,7 +1972,7 @@
           <a:p>
             <a:fld id="{4E93A57C-03BA-4B61-AE4A-2D7B848FC893}" type="datetimeFigureOut">
               <a:rPr lang="en-GB" smtClean="0"/>
-              <a:t>22/08/2025</a:t>
+              <a:t>27/08/2025</a:t>
             </a:fld>
             <a:endParaRPr lang="en-GB"/>
           </a:p>
@@ -2085,7 +2085,7 @@
           <a:p>
             <a:fld id="{4E93A57C-03BA-4B61-AE4A-2D7B848FC893}" type="datetimeFigureOut">
               <a:rPr lang="en-GB" smtClean="0"/>
-              <a:t>22/08/2025</a:t>
+              <a:t>27/08/2025</a:t>
             </a:fld>
             <a:endParaRPr lang="en-GB"/>
           </a:p>
@@ -2398,7 +2398,7 @@
           <a:p>
             <a:fld id="{4E93A57C-03BA-4B61-AE4A-2D7B848FC893}" type="datetimeFigureOut">
               <a:rPr lang="en-GB" smtClean="0"/>
-              <a:t>22/08/2025</a:t>
+              <a:t>27/08/2025</a:t>
             </a:fld>
             <a:endParaRPr lang="en-GB"/>
           </a:p>
@@ -2687,7 +2687,7 @@
           <a:p>
             <a:fld id="{4E93A57C-03BA-4B61-AE4A-2D7B848FC893}" type="datetimeFigureOut">
               <a:rPr lang="en-GB" smtClean="0"/>
-              <a:t>22/08/2025</a:t>
+              <a:t>27/08/2025</a:t>
             </a:fld>
             <a:endParaRPr lang="en-GB"/>
           </a:p>
@@ -2930,7 +2930,7 @@
           <a:p>
             <a:fld id="{4E93A57C-03BA-4B61-AE4A-2D7B848FC893}" type="datetimeFigureOut">
               <a:rPr lang="en-GB" smtClean="0"/>
-              <a:t>22/08/2025</a:t>
+              <a:t>27/08/2025</a:t>
             </a:fld>
             <a:endParaRPr lang="en-GB"/>
           </a:p>
@@ -3800,10 +3800,10 @@
           </p:nvGrpSpPr>
           <p:grpSpPr>
             <a:xfrm>
-              <a:off x="4631428" y="4401751"/>
-              <a:ext cx="2218924" cy="1142531"/>
-              <a:chOff x="4631428" y="4401751"/>
-              <a:chExt cx="2218924" cy="1142531"/>
+              <a:off x="4631428" y="4354904"/>
+              <a:ext cx="2225448" cy="1291499"/>
+              <a:chOff x="4631428" y="4354904"/>
+              <a:chExt cx="2225448" cy="1291499"/>
             </a:xfrm>
           </p:grpSpPr>
           <p:sp>
@@ -3820,7 +3820,7 @@
             </p:nvSpPr>
             <p:spPr>
               <a:xfrm>
-                <a:off x="4631428" y="5243775"/>
+                <a:off x="4635096" y="5345896"/>
                 <a:ext cx="2218923" cy="300507"/>
               </a:xfrm>
               <a:prstGeom prst="rect">
@@ -3862,7 +3862,7 @@
               <a:p>
                 <a:r>
                   <a:rPr lang="en-GB" dirty="0"/>
-                  <a:t>Prop: Thickness</a:t>
+                  <a:t>Thickness = 0</a:t>
                 </a:r>
               </a:p>
             </p:txBody>
@@ -3881,7 +3881,7 @@
             </p:nvSpPr>
             <p:spPr>
               <a:xfrm>
-                <a:off x="4631428" y="4871941"/>
+                <a:off x="4631428" y="4815841"/>
                 <a:ext cx="2218923" cy="300507"/>
               </a:xfrm>
               <a:prstGeom prst="rect">
@@ -3910,7 +3910,7 @@
               <a:p>
                 <a:r>
                   <a:rPr lang="en-GB" dirty="0"/>
-                  <a:t>SLD-Out</a:t>
+                  <a:t>SLD-Out:3</a:t>
                 </a:r>
               </a:p>
             </p:txBody>
@@ -3929,7 +3929,7 @@
             </p:nvSpPr>
             <p:spPr>
               <a:xfrm>
-                <a:off x="4631429" y="4401751"/>
+                <a:off x="4637953" y="4354904"/>
                 <a:ext cx="2218923" cy="413629"/>
               </a:xfrm>
               <a:prstGeom prst="rect">
@@ -3971,6 +3971,58 @@
                   <a:t>(Substrate roughness)</a:t>
                 </a:r>
                 <a:endParaRPr lang="en-GB" dirty="0"/>
+              </a:p>
+            </p:txBody>
+          </p:sp>
+          <p:sp>
+            <p:nvSpPr>
+              <p:cNvPr id="9" name="Rectangle 8">
+                <a:extLst>
+                  <a:ext uri="{FF2B5EF4-FFF2-40B4-BE49-F238E27FC236}">
+                    <a16:creationId xmlns:a16="http://schemas.microsoft.com/office/drawing/2014/main" id="{88113A0C-3D18-AC1F-95F0-3D7BE534FCDD}"/>
+                  </a:ext>
+                </a:extLst>
+              </p:cNvPr>
+              <p:cNvSpPr/>
+              <p:nvPr/>
+            </p:nvSpPr>
+            <p:spPr>
+              <a:xfrm>
+                <a:off x="4637952" y="5162571"/>
+                <a:ext cx="2218923" cy="300507"/>
+              </a:xfrm>
+              <a:prstGeom prst="rect">
+                <a:avLst/>
+              </a:prstGeom>
+            </p:spPr>
+            <p:style>
+              <a:lnRef idx="2">
+                <a:schemeClr val="accent1">
+                  <a:shade val="15000"/>
+                </a:schemeClr>
+              </a:lnRef>
+              <a:fillRef idx="1">
+                <a:schemeClr val="accent1"/>
+              </a:fillRef>
+              <a:effectRef idx="0">
+                <a:schemeClr val="accent1"/>
+              </a:effectRef>
+              <a:fontRef idx="minor">
+                <a:schemeClr val="lt1"/>
+              </a:fontRef>
+            </p:style>
+            <p:txBody>
+              <a:bodyPr rtlCol="0" anchor="ctr" anchorCtr="0"/>
+              <a:lstStyle/>
+              <a:p>
+                <a:r>
+                  <a:rPr lang="en-GB"/>
+                  <a:t>hydration:</a:t>
+                </a:r>
+                <a:r>
+                  <a:rPr lang="en-GB" dirty="0"/>
+                  <a:t>3</a:t>
+                </a:r>
               </a:p>
             </p:txBody>
           </p:sp>
@@ -4046,7 +4098,7 @@
               <a:p>
                 <a:r>
                   <a:rPr lang="en-GB" dirty="0"/>
-                  <a:t>Thickness:0</a:t>
+                  <a:t>Thickness = 0</a:t>
                 </a:r>
               </a:p>
             </p:txBody>
@@ -4094,7 +4146,7 @@
               <a:p>
                 <a:r>
                   <a:rPr lang="en-GB" dirty="0"/>
-                  <a:t>SLD:0</a:t>
+                  <a:t>SLD-In:          0</a:t>
                 </a:r>
               </a:p>
             </p:txBody>
@@ -4403,6 +4455,14 @@
               <a:avLst/>
             </a:prstGeom>
             <a:noFill/>
+            <a:ln w="25400">
+              <a:solidFill>
+                <a:schemeClr val="accent3">
+                  <a:lumMod val="60000"/>
+                  <a:lumOff val="40000"/>
+                </a:schemeClr>
+              </a:solidFill>
+            </a:ln>
           </p:spPr>
           <p:txBody>
             <a:bodyPr wrap="none" rtlCol="0">
@@ -4635,7 +4695,7 @@
             <a:p>
               <a:r>
                 <a:rPr lang="en-GB" dirty="0"/>
-                <a:t>Layer 0 (Bulk-in)</a:t>
+                <a:t>Bulk-in (Layer 0)</a:t>
               </a:r>
             </a:p>
           </p:txBody>
@@ -4725,7 +4785,7 @@
           <p:spPr>
             <a:xfrm>
               <a:off x="7289545" y="4726418"/>
-              <a:ext cx="1967526" cy="369332"/>
+              <a:ext cx="2014013" cy="369332"/>
             </a:xfrm>
             <a:prstGeom prst="rect">
               <a:avLst/>
@@ -4740,7 +4800,7 @@
             <a:p>
               <a:r>
                 <a:rPr lang="en-GB" dirty="0"/>
-                <a:t>Layer 3 (Bulk-Out)</a:t>
+                <a:t>Bulk-Out (Layer 3 )</a:t>
               </a:r>
             </a:p>
           </p:txBody>
@@ -4853,13 +4913,21 @@
           </p:nvSpPr>
           <p:spPr>
             <a:xfrm>
-              <a:off x="7614287" y="505413"/>
+              <a:off x="7728482" y="465482"/>
               <a:ext cx="894033" cy="369332"/>
             </a:xfrm>
             <a:prstGeom prst="rect">
               <a:avLst/>
             </a:prstGeom>
             <a:noFill/>
+            <a:ln w="25400">
+              <a:solidFill>
+                <a:schemeClr val="accent3">
+                  <a:lumMod val="60000"/>
+                  <a:lumOff val="40000"/>
+                </a:schemeClr>
+              </a:solidFill>
+            </a:ln>
           </p:spPr>
           <p:txBody>
             <a:bodyPr wrap="square" rtlCol="0">
@@ -5083,6 +5151,14 @@
               <a:avLst/>
             </a:prstGeom>
             <a:noFill/>
+            <a:ln w="25400">
+              <a:solidFill>
+                <a:schemeClr val="accent3">
+                  <a:lumMod val="60000"/>
+                  <a:lumOff val="40000"/>
+                </a:schemeClr>
+              </a:solidFill>
+            </a:ln>
           </p:spPr>
           <p:txBody>
             <a:bodyPr wrap="none" rtlCol="0">
@@ -5098,6 +5174,90 @@
           </p:txBody>
         </p:sp>
       </p:grpSp>
+      <p:cxnSp>
+        <p:nvCxnSpPr>
+          <p:cNvPr id="3" name="Straight Arrow Connector 2">
+            <a:extLst>
+              <a:ext uri="{FF2B5EF4-FFF2-40B4-BE49-F238E27FC236}">
+                <a16:creationId xmlns:a16="http://schemas.microsoft.com/office/drawing/2014/main" id="{1ED17AD8-04FB-F2D0-3327-C711B3E214E6}"/>
+              </a:ext>
+            </a:extLst>
+          </p:cNvPr>
+          <p:cNvCxnSpPr>
+            <a:stCxn id="40" idx="3"/>
+            <a:endCxn id="51" idx="1"/>
+          </p:cNvCxnSpPr>
+          <p:nvPr/>
+        </p:nvCxnSpPr>
+        <p:spPr>
+          <a:xfrm>
+            <a:off x="6416088" y="650148"/>
+            <a:ext cx="1312394" cy="0"/>
+          </a:xfrm>
+          <a:prstGeom prst="straightConnector1">
+            <a:avLst/>
+          </a:prstGeom>
+          <a:ln>
+            <a:tailEnd type="triangle"/>
+          </a:ln>
+        </p:spPr>
+        <p:style>
+          <a:lnRef idx="2">
+            <a:schemeClr val="accent1"/>
+          </a:lnRef>
+          <a:fillRef idx="0">
+            <a:schemeClr val="accent1"/>
+          </a:fillRef>
+          <a:effectRef idx="1">
+            <a:schemeClr val="accent1"/>
+          </a:effectRef>
+          <a:fontRef idx="minor">
+            <a:schemeClr val="tx1"/>
+          </a:fontRef>
+        </p:style>
+      </p:cxnSp>
+      <p:cxnSp>
+        <p:nvCxnSpPr>
+          <p:cNvPr id="8" name="Connector: Elbow 7">
+            <a:extLst>
+              <a:ext uri="{FF2B5EF4-FFF2-40B4-BE49-F238E27FC236}">
+                <a16:creationId xmlns:a16="http://schemas.microsoft.com/office/drawing/2014/main" id="{A495984B-976F-B3FF-4866-58DD757FF7E4}"/>
+              </a:ext>
+            </a:extLst>
+          </p:cNvPr>
+          <p:cNvCxnSpPr>
+            <a:stCxn id="51" idx="3"/>
+            <a:endCxn id="59" idx="1"/>
+          </p:cNvCxnSpPr>
+          <p:nvPr/>
+        </p:nvCxnSpPr>
+        <p:spPr>
+          <a:xfrm>
+            <a:off x="8622515" y="650148"/>
+            <a:ext cx="1137071" cy="2243483"/>
+          </a:xfrm>
+          <a:prstGeom prst="bentConnector2">
+            <a:avLst/>
+          </a:prstGeom>
+          <a:ln>
+            <a:tailEnd type="triangle"/>
+          </a:ln>
+        </p:spPr>
+        <p:style>
+          <a:lnRef idx="2">
+            <a:schemeClr val="accent1"/>
+          </a:lnRef>
+          <a:fillRef idx="0">
+            <a:schemeClr val="accent1"/>
+          </a:fillRef>
+          <a:effectRef idx="1">
+            <a:schemeClr val="accent1"/>
+          </a:effectRef>
+          <a:fontRef idx="minor">
+            <a:schemeClr val="tx1"/>
+          </a:fontRef>
+        </p:style>
+      </p:cxnSp>
     </p:spTree>
     <p:extLst>
       <p:ext uri="{BB962C8B-B14F-4D97-AF65-F5344CB8AC3E}">

</xml_diff>